<commit_message>
Fix final report and slides limitation wording
</commit_message>
<xml_diff>
--- a/final/slides/Image_Processing_Project_Final_Presentation.pptx
+++ b/final/slides/Image_Processing_Project_Final_Presentation.pptx
@@ -7658,7 +7658,7 @@
         <p:spPr>
           <a:xfrm>
             <a:off x="969264" y="4846320"/>
-            <a:ext cx="2971800" cy="868680"/>
+            <a:ext cx="2971800" cy="901529"/>
           </a:xfrm>
           <a:prstGeom prst="rect">
             <a:avLst/>
@@ -7683,14 +7683,42 @@
               </a:spcAft>
             </a:pPr>
             <a:r>
-              <a:rPr sz="1250" b="0" i="0">
+              <a:rPr lang="en-US" sz="1250" b="0" i="0">
                 <a:solidFill>
                   <a:srgbClr val="6E7C84"/>
                 </a:solidFill>
                 <a:latin typeface="Calibri"/>
               </a:rPr>
-              <a:t>Seeds 599310825 / 440213415 score only ≈ 55–56 raw reward.</a:t>
-            </a:r>
+              <a:t>Qualitative limitation clips</a:t>
+            </a:r>
+          </a:p>
+          <a:p>
+            <a:pPr algn="l">
+              <a:lnSpc>
+                <a:spcPct val="112000"/>
+              </a:lnSpc>
+              <a:spcBef>
+                <a:spcPts val="0"/>
+              </a:spcBef>
+              <a:spcAft>
+                <a:spcPts val="400"/>
+              </a:spcAft>
+            </a:pPr>
+            <a:r>
+              <a:rPr lang="en-US" sz="1250" b="0" i="0">
+                <a:solidFill>
+                  <a:srgbClr val="6E7C84"/>
+                </a:solidFill>
+                <a:latin typeface="Calibri"/>
+              </a:rPr>
+              <a:t>Some high-reward episodes still show unstable recovery, brief off-road drift, or sharp-turn weakness.</a:t>
+            </a:r>
+            <a:endParaRPr sz="1250" b="0" i="0">
+              <a:solidFill>
+                <a:srgbClr val="6E7C84"/>
+              </a:solidFill>
+              <a:latin typeface="Calibri"/>
+            </a:endParaRPr>
           </a:p>
         </p:txBody>
       </p:sp>
@@ -8660,8 +8688,8 @@
         </p:nvSpPr>
         <p:spPr>
           <a:xfrm>
-            <a:off x="1143000" y="5669280"/>
-            <a:ext cx="7955279" cy="868680"/>
+            <a:off x="1143000" y="5853327"/>
+            <a:ext cx="7955279" cy="500586"/>
           </a:xfrm>
           <a:prstGeom prst="rect">
             <a:avLst/>
@@ -8686,40 +8714,13 @@
               </a:spcAft>
             </a:pPr>
             <a:r>
-              <a:rPr sz="1500" b="1" i="0" dirty="0">
+              <a:rPr lang="en-US" sz="1500" b="1" i="0">
                 <a:solidFill>
                   <a:srgbClr val="E8833A"/>
                 </a:solidFill>
                 <a:latin typeface="Calibri"/>
               </a:rPr>
-              <a:t>GitHub   </a:t>
-            </a:r>
-            <a:r>
-              <a:rPr sz="1500" b="1" i="0" dirty="0">
-                <a:solidFill>
-                  <a:srgbClr val="FFFFFF"/>
-                </a:solidFill>
-                <a:latin typeface="Consolas"/>
-              </a:rPr>
-              <a:t>github.com/</a:t>
-            </a:r>
-            <a:r>
-              <a:rPr sz="1500" b="1" i="0" dirty="0" err="1">
-                <a:solidFill>
-                  <a:srgbClr val="FFFFFF"/>
-                </a:solidFill>
-                <a:latin typeface="Consolas"/>
-              </a:rPr>
-              <a:t>UltraLamb</a:t>
-            </a:r>
-            <a:r>
-              <a:rPr sz="1500" b="1" i="0" dirty="0">
-                <a:solidFill>
-                  <a:srgbClr val="FFFFFF"/>
-                </a:solidFill>
-                <a:latin typeface="Consolas"/>
-              </a:rPr>
-              <a:t>/Image-Processing-Project</a:t>
+              <a:t>GitHub</a:t>
             </a:r>
           </a:p>
           <a:p>
@@ -8731,18 +8732,24 @@
                 <a:spcPts val="0"/>
               </a:spcBef>
               <a:spcAft>
-                <a:spcPts val="400"/>
-              </a:spcAft>
-            </a:pPr>
-            <a:r>
-              <a:rPr sz="1150" b="0" i="1" dirty="0">
-                <a:solidFill>
-                  <a:srgbClr val="CFE3E6"/>
+                <a:spcPts val="200"/>
+              </a:spcAft>
+            </a:pPr>
+            <a:r>
+              <a:rPr lang="en-US" sz="1500" b="1" i="0">
+                <a:solidFill>
+                  <a:srgbClr val="E8833A"/>
                 </a:solidFill>
                 <a:latin typeface="Calibri"/>
               </a:rPr>
-              <a:t>submit after the repository is renamed to “Image-Processing-Project”</a:t>
-            </a:r>
+              <a:t>https://github.com/UltraLamb/Image-Processing-Project</a:t>
+            </a:r>
+            <a:endParaRPr sz="1150" b="0" i="1" dirty="0">
+              <a:solidFill>
+                <a:srgbClr val="CFE3E6"/>
+              </a:solidFill>
+              <a:latin typeface="Calibri"/>
+            </a:endParaRPr>
           </a:p>
         </p:txBody>
       </p:sp>

</xml_diff>